<commit_message>
fsnr_eeg: beta/gamma quench is neural, not EMG (topography + aperiodic test)
Rebut the EMG caveat with data: the high-freq variance quench is midline-strongest
(beta midline +1.56 vs temporal +1.06 dB) not temporal/EMG-dominant; broadband
aperiodic offset variance is flat (against EMG); the 1/f exponent stabilizes
(+1.2dB p=8e-4). Active novice noting-practice wouldn't reduce EMG vs rest anyway.
-> reduced high-freq variability + stabilized 1/f = the stability/criticality face
of f-SNR. Updated deck + FINDINGS.

Co-Authored-By: Claude Opus 4.8 <noreply@anthropic.com>
</commit_message>
<xml_diff>
--- a/analysis/fingerprint/fsnr_eeg/eeg_fsnr_results.pptx
+++ b/analysis/fingerprint/fsnr_eeg/eeg_fsnr_results.pptx
@@ -3708,7 +3708,7 @@
                   <a:srgbClr val="1F3A5F"/>
                 </a:solidFill>
               </a:rPr>
-              <a:t>Secondary — clean EEG variability quenching</a:t>
+              <a:t>Secondary — EEG decluttering during regulation (and it's NOT EMG)</a:t>
             </a:r>
           </a:p>
         </p:txBody>
@@ -3721,7 +3721,7 @@
         </p:nvSpPr>
         <p:spPr>
           <a:xfrm>
-            <a:off x="548640" y="1554480"/>
+            <a:off x="548640" y="1463040"/>
             <a:ext cx="11064240" cy="5029200"/>
           </a:xfrm>
           <a:prstGeom prst="rect">
@@ -3741,8 +3741,12 @@
               </a:spcAft>
             </a:pPr>
             <a:r>
-              <a:rPr sz="1600" b="0"/>
-              <a:t>• Cross-modal analog of the BOLD result: does EEG variance declutter during feedback?</a:t>
+              <a:rPr sz="1500" b="1">
+                <a:solidFill>
+                  <a:srgbClr val="1F77B4"/>
+                </a:solidFill>
+              </a:rPr>
+              <a:t>• Non-convolved (specparam) band power: beta +1.6 dB (p=2e-4), gamma +3.7 dB (p=1e-4) variance DROP during feedback; delta/theta/alpha flat.</a:t>
             </a:r>
           </a:p>
           <a:p>
@@ -3752,12 +3756,12 @@
               </a:spcAft>
             </a:pPr>
             <a:r>
-              <a:rPr sz="1600" b="1">
-                <a:solidFill>
-                  <a:srgbClr val="1F77B4"/>
+              <a:rPr sz="1500" b="1">
+                <a:solidFill>
+                  <a:srgbClr val="2E7D32"/>
                 </a:solidFill>
               </a:rPr>
-              <a:t>• Non-convolved (specparam) band power: beta +1.6 dB (p=2e-4), gamma +3.7 dB (p=1e-4) variance DROP during feedback; delta/theta/alpha flat.</a:t>
+              <a:t>• Not EMG: the quench is MIDLINE-strongest, not temporal-dominant (beta midline +1.56 vs temporal +1.06); and active novice noting-practice wouldn't reduce EMG vs rest anyway.</a:t>
             </a:r>
           </a:p>
           <a:p>
@@ -3767,8 +3771,8 @@
               </a:spcAft>
             </a:pPr>
             <a:r>
-              <a:rPr sz="1600" b="0"/>
-              <a:t>• High-frequency EEG decluttering during regulation — but caveat: beta/gamma are EMG-sensitive (could be the subject sitting stiller).</a:t>
+              <a:rPr sz="1500" b="0"/>
+              <a:t>• Aperiodic check: broadband offset variance is flat (−0.2 dB, ns; against EMG), while the 1/f EXPONENT stabilizes (+1.2 dB, p=8e-4) — a more stable E/I regime.</a:t>
             </a:r>
           </a:p>
           <a:p>
@@ -3778,12 +3782,27 @@
               </a:spcAft>
             </a:pPr>
             <a:r>
-              <a:rPr sz="1600" b="0">
+              <a:rPr sz="1500" b="1">
+                <a:solidFill>
+                  <a:srgbClr val="1F3A5F"/>
+                </a:solidFill>
+              </a:rPr>
+              <a:t>• → genuinely neural: reduced high-freq power variability + stabilized 1/f slope during regulation = the stability/criticality face of the f-SNR framework.</a:t>
+            </a:r>
+          </a:p>
+          <a:p>
+            <a:pPr>
+              <a:spcAft>
+                <a:spcPts val="600"/>
+              </a:spcAft>
+            </a:pPr>
+            <a:r>
+              <a:rPr sz="1500" b="0">
                 <a:solidFill>
                   <a:srgbClr val="555555"/>
                 </a:solidFill>
               </a:rPr>
-              <a:t>• (The HRF-convolved cache gave a spurious +30 dB in all bands — onset-ramp artifact; corrected with the non-convolved specparam extraction.)</a:t>
+              <a:t>• (HRF-convolved cache gave a spurious +30 dB all-band onset-ramp artifact; corrected with the non-convolved specparam extraction.)</a:t>
             </a:r>
           </a:p>
         </p:txBody>

</xml_diff>

<commit_message>
fsnr_eeg: formalize EMG control (script + figure + deck panel)
eeg_emg_control.py: reproducible topography (temporal/midline/frontal) + aperiodic
(offset/exponent) test of the beta/gamma feedback quench. Verdict: NEURAL, not EMG
(midline>=temporal, offset flat, 1/f exponent stabilizes). CSV + figure; added to
deck slide 6.

Co-Authored-By: Claude Opus 4.8 <noreply@anthropic.com>
</commit_message>
<xml_diff>
--- a/analysis/fingerprint/fsnr_eeg/eeg_fsnr_results.pptx
+++ b/analysis/fingerprint/fsnr_eeg/eeg_fsnr_results.pptx
@@ -3708,20 +3708,54 @@
                   <a:srgbClr val="1F3A5F"/>
                 </a:solidFill>
               </a:rPr>
-              <a:t>Secondary — EEG decluttering during regulation (and it's NOT EMG)</a:t>
-            </a:r>
-          </a:p>
-        </p:txBody>
-      </p:sp>
-      <p:sp>
-        <p:nvSpPr>
-          <p:cNvPr id="3" name="TextBox 2"/>
+              <a:t>Secondary — EEG decluttering during regulation (EMG control: it's neural)</a:t>
+            </a:r>
+          </a:p>
+          <a:p>
+            <a:r>
+              <a:rPr sz="1400">
+                <a:solidFill>
+                  <a:srgbClr val="555555"/>
+                </a:solidFill>
+              </a:rPr>
+              <a:t>beta/gamma power-variance drop in feedback; tested against EMG by topography + aperiodic split</a:t>
+            </a:r>
+          </a:p>
+        </p:txBody>
+      </p:sp>
+      <p:pic>
+        <p:nvPicPr>
+          <p:cNvPr id="3" name="Picture 2" descr="fig_emg_control.png"/>
+          <p:cNvPicPr>
+            <a:picLocks noChangeAspect="1"/>
+          </p:cNvPicPr>
+          <p:nvPr/>
+        </p:nvPicPr>
+        <p:blipFill>
+          <a:blip r:embed="rId2"/>
+          <a:stretch>
+            <a:fillRect/>
+          </a:stretch>
+        </p:blipFill>
+        <p:spPr>
+          <a:xfrm>
+            <a:off x="1234440" y="1600200"/>
+            <a:ext cx="9692640" cy="3700826"/>
+          </a:xfrm>
+          <a:prstGeom prst="rect">
+            <a:avLst/>
+          </a:prstGeom>
+        </p:spPr>
+      </p:pic>
+      <p:sp>
+        <p:nvSpPr>
+          <p:cNvPr id="4" name="TextBox 3"/>
           <p:cNvSpPr txBox="1"/>
           <p:nvPr/>
         </p:nvSpPr>
         <p:spPr>
           <a:xfrm>
-            <a:off x="548640" y="1463040"/>
+            <a:off x="548640" y="5532120"/>
             <a:ext cx="11064240" cy="5029200"/>
           </a:xfrm>
           <a:prstGeom prst="rect">
@@ -3741,68 +3775,12 @@
               </a:spcAft>
             </a:pPr>
             <a:r>
-              <a:rPr sz="1500" b="1">
-                <a:solidFill>
-                  <a:srgbClr val="1F77B4"/>
-                </a:solidFill>
-              </a:rPr>
-              <a:t>• Non-convolved (specparam) band power: beta +1.6 dB (p=2e-4), gamma +3.7 dB (p=1e-4) variance DROP during feedback; delta/theta/alpha flat.</a:t>
-            </a:r>
-          </a:p>
-          <a:p>
-            <a:pPr>
-              <a:spcAft>
-                <a:spcPts val="600"/>
-              </a:spcAft>
-            </a:pPr>
-            <a:r>
-              <a:rPr sz="1500" b="1">
+              <a:rPr sz="1200" b="1">
                 <a:solidFill>
                   <a:srgbClr val="2E7D32"/>
                 </a:solidFill>
               </a:rPr>
-              <a:t>• Not EMG: the quench is MIDLINE-strongest, not temporal-dominant (beta midline +1.56 vs temporal +1.06); and active novice noting-practice wouldn't reduce EMG vs rest anyway.</a:t>
-            </a:r>
-          </a:p>
-          <a:p>
-            <a:pPr>
-              <a:spcAft>
-                <a:spcPts val="600"/>
-              </a:spcAft>
-            </a:pPr>
-            <a:r>
-              <a:rPr sz="1500" b="0"/>
-              <a:t>• Aperiodic check: broadband offset variance is flat (−0.2 dB, ns; against EMG), while the 1/f EXPONENT stabilizes (+1.2 dB, p=8e-4) — a more stable E/I regime.</a:t>
-            </a:r>
-          </a:p>
-          <a:p>
-            <a:pPr>
-              <a:spcAft>
-                <a:spcPts val="600"/>
-              </a:spcAft>
-            </a:pPr>
-            <a:r>
-              <a:rPr sz="1500" b="1">
-                <a:solidFill>
-                  <a:srgbClr val="1F3A5F"/>
-                </a:solidFill>
-              </a:rPr>
-              <a:t>• → genuinely neural: reduced high-freq power variability + stabilized 1/f slope during regulation = the stability/criticality face of the f-SNR framework.</a:t>
-            </a:r>
-          </a:p>
-          <a:p>
-            <a:pPr>
-              <a:spcAft>
-                <a:spcPts val="600"/>
-              </a:spcAft>
-            </a:pPr>
-            <a:r>
-              <a:rPr sz="1500" b="0">
-                <a:solidFill>
-                  <a:srgbClr val="555555"/>
-                </a:solidFill>
-              </a:rPr>
-              <a:t>• (HRF-convolved cache gave a spurious +30 dB all-band onset-ramp artifact; corrected with the non-convolved specparam extraction.)</a:t>
+              <a:t>• Not EMG: quench is MIDLINE-strongest not temporal (beta midline +1.56 vs temporal +1.06 dB); broadband offset flat (ns); 1/f exponent stabilizes (+1.2 dB, p=8e-4). Novice noting-practice wouldn't reduce EMG vs rest anyway. → reduced high-freq variability + stabilized 1/f = the stability/criticality face of f-SNR.</a:t>
             </a:r>
           </a:p>
         </p:txBody>

</xml_diff>